<commit_message>
Update Nautech decks with confirmed pricing, status and terms
Pricing 1 000 kr per module / 14 000 kr full coverage, data stored in
Norway, DNV path, 1-2 week onboarding, included support, pilot terms
and LOI / Innovasjon Norge status.

Co-Authored-By: Claude Opus 5.5 <noreply@anthropic.com>
Claude-Session: https://claude.ai/code/session_01CQjopvhNkiFigVjRSDBJn2
</commit_message>
<xml_diff>
--- a/presentasjoner/Nautech - Investorpresentasjon v2.pptx
+++ b/presentasjoner/Nautech - Investorpresentasjon v2.pptx
@@ -119,7 +119,7 @@
   <p:extLst>
     <p:ext uri="{521415D9-36F7-43E2-AB2F-B90AF26B5E84}">
       <p14:sectionLst xmlns:p14="http://schemas.microsoft.com/office/powerpoint/2010/main">
-        <p14:section name="Problem og løsning" id="{ceed070d-3532-31f5-6826-395022b5978f}">
+        <p14:section name="Problem og løsning" id="{a060b11a-3eae-a531-ad3e-437ee1c608dc}">
           <p14:sldIdLst>
             <p14:sldId id="256"/>
             <p14:sldId id="257"/>
@@ -129,21 +129,21 @@
             <p14:sldId id="261"/>
           </p14:sldIdLst>
         </p14:section>
-        <p14:section name="Marked og konkurranse" id="{656b5d65-3944-77c1-bdf9-36845bd1b813}">
+        <p14:section name="Marked og konkurranse" id="{eb10bd58-3f99-e55c-014e-048973ebbc93}">
           <p14:sldIdLst>
             <p14:sldId id="262"/>
             <p14:sldId id="263"/>
             <p14:sldId id="264"/>
           </p14:sldIdLst>
         </p14:section>
-        <p14:section name="Selskap og plan" id="{15d0b194-39eb-c04a-8962-4c785d8851b4}">
+        <p14:section name="Selskap og plan" id="{145fdd4e-02cb-1b54-0ff2-208c16b4b6fb}">
           <p14:sldIdLst>
             <p14:sldId id="265"/>
             <p14:sldId id="266"/>
             <p14:sldId id="267"/>
           </p14:sldIdLst>
         </p14:section>
-        <p14:section name="Vedlegg" id="{b1409484-1f0a-947b-882f-103eea6e0e30}">
+        <p14:section name="Vedlegg" id="{05e605cd-2d34-efcd-7ee8-3b86406472cb}">
           <p14:sldIdLst>
             <p14:sldId id="268"/>
           </p14:sldIdLst>
@@ -272,16 +272,16 @@
                 <c:formatCode>General</c:formatCode>
                 <c:ptCount val="4"/>
                 <c:pt idx="0">
-                  <c:v>1.2</c:v>
+                  <c:v>1.68</c:v>
                 </c:pt>
                 <c:pt idx="1">
-                  <c:v>6</c:v>
+                  <c:v>8.4</c:v>
                 </c:pt>
                 <c:pt idx="2">
-                  <c:v>12</c:v>
+                  <c:v>16.8</c:v>
                 </c:pt>
                 <c:pt idx="3">
-                  <c:v>31.2</c:v>
+                  <c:v>43.68</c:v>
                 </c:pt>
               </c:numCache>
             </c:numRef>
@@ -816,7 +816,7 @@
           <a:p>
             <a:r>
               <a:rPr lang="en-US" dirty="0"/>
-              <a:t>Nautech er et komplett system for drift og vedlikehold av fiskefartøy. Det er laget av folk som har jobbet om bord, og har en KI-assistent som svarer ut fra rederiets egne data. Produktet er ferdig utviklet, og vi er i samtaler med de første rederiene.</a:t>
+              <a:t>Nautech er et komplett system for drift og vedlikehold av fiskefartøy. Det er laget av folk som har jobbet om bord, og har en KI-assistent som svarer ut fra rederiets egne data. MVP-en er klar, vi har kontaktet rederier i hele Norge, og flere har vist interesse.</a:t>
             </a:r>
             <a:endParaRPr lang="en-US" dirty="0"/>
           </a:p>
@@ -904,7 +904,7 @@
           <a:p>
             <a:r>
               <a:rPr lang="en-US" dirty="0"/>
-              <a:t>Produktet er ferdig utviklet. Nå er vi i samtaler med rederier. Neste milepæl er en pilot på ett fartøy, deretter første betalende rederi. Innen 18 måneder vil vi ha et antall fartøy i drift og den første kunden utenfor Norge.</a:t>
+              <a:t>MVP-en er klar, og vi har kontaktet rederier i hele Norge. Flere har vist interesse, og vi jobber nå med å signere intensjonsavtaler. De utløser også neste støtterunde fra Innovasjon Norge. Deretter kommer pilot og første betalende kunde. Produktet er bygget etter DNVs krav, og vi søker godkjenning når det er ferdig utviklet.</a:t>
             </a:r>
             <a:endParaRPr lang="en-US" dirty="0"/>
           </a:p>
@@ -1784,7 +1784,7 @@
           <a:p>
             <a:r>
               <a:rPr lang="en-US" dirty="0"/>
-              <a:t>Norge er hjemmemarkedet vårt, med rundt 260 fiskefartøy over 28 meter. Det tilsvarer rundt 31 millioner i årlig abonnement. Samme type fartøy finnes i EU, med rundt 2 270 fartøy over 24 meter. Til sammen er første målgruppe rundt 300 millioner kroner i året, før vi regner med havbruk og andre land.</a:t>
+              <a:t>Norge er hjemmemarkedet vårt, med rundt 260 fiskefartøy over 28 meter. Med full dekning tilsvarer det rundt 44 millioner i årlig abonnement. Samme type fartøy finnes i EU, med rundt 2 270 fartøy over 24 meter. Til sammen er første målgruppe rundt 425 millioner kroner i året, før vi regner med havbruk og andre land.</a:t>
             </a:r>
             <a:endParaRPr lang="en-US" dirty="0"/>
           </a:p>
@@ -1872,7 +1872,7 @@
           <a:p>
             <a:r>
               <a:rPr lang="en-US" dirty="0"/>
-              <a:t>Modellen er enkel: et fast abonnement per fartøy. Ti fartøy gir 1,2 millioner i året. Når et rederi først har tatt i bruk et vedlikeholdssystem, bytter de sjelden, så inntektene er stabile.</a:t>
+              <a:t>Modellen er enkel: 1 000 kroner per modul per fartøy i måneden, 14 000 for alle modulene. Ti fartøy med full dekning gir 1,7 millioner i året. Når et rederi først har tatt i bruk et vedlikeholdssystem, bytter de sjelden, så inntektene er stabile.</a:t>
             </a:r>
             <a:endParaRPr lang="en-US" dirty="0"/>
           </a:p>
@@ -2846,7 +2846,7 @@
                 <a:ea typeface="Calibri" pitchFamily="34" charset="-122"/>
                 <a:cs typeface="Calibri" pitchFamily="34" charset="-120"/>
               </a:rPr>
-              <a:t>Bygget av en maskinsjef fra fiskeflåten. Ferdig utviklet. Klar for de første rederiene.</a:t>
+              <a:t>Bygget av en maskinsjef fra fiskeflåten. MVP klar. Rederier i hele Norge er kontaktet.</a:t>
             </a:r>
             <a:endParaRPr lang="en-US" sz="1800" dirty="0"/>
           </a:p>
@@ -3195,7 +3195,7 @@
                 <a:ea typeface="Calibri" pitchFamily="34" charset="-122"/>
                 <a:cs typeface="Calibri" pitchFamily="34" charset="-120"/>
               </a:rPr>
-              <a:t>Data i Norge/EU</a:t>
+              <a:t>Data i Norge</a:t>
             </a:r>
             <a:endParaRPr lang="en-US" sz="1800" dirty="0"/>
           </a:p>
@@ -3397,7 +3397,7 @@
                 <a:ea typeface="Arial" pitchFamily="34" charset="-122"/>
                 <a:cs typeface="Arial" pitchFamily="34" charset="-120"/>
               </a:rPr>
-              <a:t>Produktet er ferdig. Nå skal det i drift hos de første rederiene</a:t>
+              <a:t>MVP-en er klar. Nå skal den i drift hos de første rederiene</a:t>
             </a:r>
             <a:endParaRPr lang="en-US" sz="3000" dirty="0"/>
           </a:p>
@@ -3523,7 +3523,7 @@
                 <a:ea typeface="Calibri" pitchFamily="34" charset="-122"/>
                 <a:cs typeface="Calibri" pitchFamily="34" charset="-120"/>
               </a:rPr>
-              <a:t>Nautech utviklet: 14 moduler og KI-assistent</a:t>
+              <a:t>MVP med 14 moduler og KI-assistent</a:t>
             </a:r>
             <a:endParaRPr lang="en-US" sz="1500" dirty="0"/>
           </a:p>
@@ -3626,35 +3626,7 @@
                 <a:ea typeface="Calibri" pitchFamily="34" charset="-122"/>
                 <a:cs typeface="Calibri" pitchFamily="34" charset="-120"/>
               </a:rPr>
-              <a:t>Samtaler med </a:t>
-            </a:r>
-            <a:pPr algn="ctr" indent="0" marL="0">
-              <a:buNone/>
-            </a:pPr>
-            <a:r>
-              <a:rPr lang="en-US" sz="1500" b="1" dirty="0">
-                <a:solidFill>
-                  <a:srgbClr val="E8751A"/>
-                </a:solidFill>
-                <a:latin typeface="Calibri" pitchFamily="34" charset="0"/>
-                <a:ea typeface="Calibri" pitchFamily="34" charset="-122"/>
-                <a:cs typeface="Calibri" pitchFamily="34" charset="-120"/>
-              </a:rPr>
-              <a:t>[FYLL INN: antall]</a:t>
-            </a:r>
-            <a:pPr algn="ctr" indent="0" marL="0">
-              <a:buNone/>
-            </a:pPr>
-            <a:r>
-              <a:rPr lang="en-US" sz="1500" dirty="0">
-                <a:solidFill>
-                  <a:srgbClr val="1B2A38"/>
-                </a:solidFill>
-                <a:latin typeface="Calibri" pitchFamily="34" charset="0"/>
-                <a:ea typeface="Calibri" pitchFamily="34" charset="-122"/>
-                <a:cs typeface="Calibri" pitchFamily="34" charset="-120"/>
-              </a:rPr>
-              <a:t> rederier</a:t>
+              <a:t>Rederier i hele Norge kontaktet. Flere har vist interesse.</a:t>
             </a:r>
             <a:endParaRPr lang="en-US" sz="1500" dirty="0"/>
           </a:p>
@@ -3710,17 +3682,17 @@
               <a:buNone/>
             </a:pPr>
             <a:r>
-              <a:rPr lang="en-US" sz="1600" b="1" dirty="0">
-                <a:solidFill>
-                  <a:srgbClr val="E8751A"/>
-                </a:solidFill>
-                <a:latin typeface="Calibri" pitchFamily="34" charset="0"/>
-                <a:ea typeface="Calibri" pitchFamily="34" charset="-122"/>
-                <a:cs typeface="Calibri" pitchFamily="34" charset="-120"/>
-              </a:rPr>
-              <a:t>[FYLL INN: dato]</a:t>
-            </a:r>
-            <a:endParaRPr lang="en-US" sz="1600" dirty="0"/>
+              <a:rPr lang="en-US" sz="1400" b="1" spc="100" kern="0" dirty="0">
+                <a:solidFill>
+                  <a:srgbClr val="0E7C86"/>
+                </a:solidFill>
+                <a:latin typeface="Calibri" pitchFamily="34" charset="0"/>
+                <a:ea typeface="Calibri" pitchFamily="34" charset="-122"/>
+                <a:cs typeface="Calibri" pitchFamily="34" charset="-120"/>
+              </a:rPr>
+              <a:t>NESTE</a:t>
+            </a:r>
+            <a:endParaRPr lang="en-US" sz="1400" dirty="0"/>
           </a:p>
         </p:txBody>
       </p:sp>
@@ -3757,7 +3729,7 @@
                 <a:ea typeface="Calibri" pitchFamily="34" charset="-122"/>
                 <a:cs typeface="Calibri" pitchFamily="34" charset="-120"/>
               </a:rPr>
-              <a:t>Pilot på første fartøy</a:t>
+              <a:t>Signerte intensjonsavtaler og neste støtterunde fra Innovasjon Norge</a:t>
             </a:r>
             <a:endParaRPr lang="en-US" sz="1500" dirty="0"/>
           </a:p>
@@ -3813,17 +3785,17 @@
               <a:buNone/>
             </a:pPr>
             <a:r>
-              <a:rPr lang="en-US" sz="1600" b="1" dirty="0">
-                <a:solidFill>
-                  <a:srgbClr val="E8751A"/>
-                </a:solidFill>
-                <a:latin typeface="Calibri" pitchFamily="34" charset="0"/>
-                <a:ea typeface="Calibri" pitchFamily="34" charset="-122"/>
-                <a:cs typeface="Calibri" pitchFamily="34" charset="-120"/>
-              </a:rPr>
-              <a:t>[FYLL INN: dato]</a:t>
-            </a:r>
-            <a:endParaRPr lang="en-US" sz="1600" dirty="0"/>
+              <a:rPr lang="en-US" sz="1400" b="1" spc="100" kern="0" dirty="0">
+                <a:solidFill>
+                  <a:srgbClr val="0E7C86"/>
+                </a:solidFill>
+                <a:latin typeface="Calibri" pitchFamily="34" charset="0"/>
+                <a:ea typeface="Calibri" pitchFamily="34" charset="-122"/>
+                <a:cs typeface="Calibri" pitchFamily="34" charset="-120"/>
+              </a:rPr>
+              <a:t>DERETTER</a:t>
+            </a:r>
+            <a:endParaRPr lang="en-US" sz="1400" dirty="0"/>
           </a:p>
         </p:txBody>
       </p:sp>
@@ -3860,7 +3832,7 @@
                 <a:ea typeface="Calibri" pitchFamily="34" charset="-122"/>
                 <a:cs typeface="Calibri" pitchFamily="34" charset="-120"/>
               </a:rPr>
-              <a:t>Første betalende rederi</a:t>
+              <a:t>Pilot på første fartøy og første betalende rederi</a:t>
             </a:r>
             <a:endParaRPr lang="en-US" sz="1500" dirty="0"/>
           </a:p>
@@ -3916,17 +3888,17 @@
               <a:buNone/>
             </a:pPr>
             <a:r>
-              <a:rPr lang="en-US" sz="1600" b="1" dirty="0">
-                <a:solidFill>
-                  <a:srgbClr val="E8751A"/>
-                </a:solidFill>
-                <a:latin typeface="Calibri" pitchFamily="34" charset="0"/>
-                <a:ea typeface="Calibri" pitchFamily="34" charset="-122"/>
-                <a:cs typeface="Calibri" pitchFamily="34" charset="-120"/>
-              </a:rPr>
-              <a:t>[FYLL INN: dato]</a:t>
-            </a:r>
-            <a:endParaRPr lang="en-US" sz="1600" dirty="0"/>
+              <a:rPr lang="en-US" sz="1400" b="1" spc="100" kern="0" dirty="0">
+                <a:solidFill>
+                  <a:srgbClr val="0E7C86"/>
+                </a:solidFill>
+                <a:latin typeface="Calibri" pitchFamily="34" charset="0"/>
+                <a:ea typeface="Calibri" pitchFamily="34" charset="-122"/>
+                <a:cs typeface="Calibri" pitchFamily="34" charset="-120"/>
+              </a:rPr>
+              <a:t>MÅL</a:t>
+            </a:r>
+            <a:endParaRPr lang="en-US" sz="1400" dirty="0"/>
           </a:p>
         </p:txBody>
       </p:sp>
@@ -3963,7 +3935,7 @@
                 <a:ea typeface="Calibri" pitchFamily="34" charset="-122"/>
                 <a:cs typeface="Calibri" pitchFamily="34" charset="-120"/>
               </a:rPr>
-              <a:t>10 fartøy i drift, første kunde utenfor Norge</a:t>
+              <a:t>Ferdig produkt med DNV-godkjenning</a:t>
             </a:r>
             <a:endParaRPr lang="en-US" sz="1500" dirty="0"/>
           </a:p>
@@ -4038,35 +4010,7 @@
                 <a:ea typeface="Calibri" pitchFamily="34" charset="-122"/>
                 <a:cs typeface="Calibri" pitchFamily="34" charset="-120"/>
               </a:rPr>
-              <a:t>vise at rederier tar Nautech i bruk og betaler for det – med </a:t>
-            </a:r>
-            <a:pPr indent="0" marL="0">
-              <a:buNone/>
-            </a:pPr>
-            <a:r>
-              <a:rPr lang="en-US" sz="1600" b="1" dirty="0">
-                <a:solidFill>
-                  <a:srgbClr val="E8751A"/>
-                </a:solidFill>
-                <a:latin typeface="Calibri" pitchFamily="34" charset="0"/>
-                <a:ea typeface="Calibri" pitchFamily="34" charset="-122"/>
-                <a:cs typeface="Calibri" pitchFamily="34" charset="-120"/>
-              </a:rPr>
-              <a:t>[FYLL INN: antall fartøy]</a:t>
-            </a:r>
-            <a:pPr indent="0" marL="0">
-              <a:buNone/>
-            </a:pPr>
-            <a:r>
-              <a:rPr lang="en-US" sz="1600" dirty="0">
-                <a:solidFill>
-                  <a:srgbClr val="1B2A38"/>
-                </a:solidFill>
-                <a:latin typeface="Calibri" pitchFamily="34" charset="0"/>
-                <a:ea typeface="Calibri" pitchFamily="34" charset="-122"/>
-                <a:cs typeface="Calibri" pitchFamily="34" charset="-120"/>
-              </a:rPr>
-              <a:t> i drift.</a:t>
+              <a:t>signerte intensjonsavtaler, de første betalende rederiene og et ferdig produkt godkjent av DNV.</a:t>
             </a:r>
             <a:endParaRPr lang="en-US" sz="1600" dirty="0"/>
           </a:p>
@@ -5175,7 +5119,7 @@
                 <a:ea typeface="Calibri" pitchFamily="34" charset="-122"/>
                 <a:cs typeface="Calibri" pitchFamily="34" charset="-120"/>
               </a:rPr>
-              <a:t>Et fiskerederi som tar Nautech i bruk på ett fartøy, gir oss ærlig tilbakemelding og blir vår første referansekunde.</a:t>
+              <a:t>Et fiskerederi som signerer en intensjonsavtale, tester Nautech på ett fartøy og blir vår første referansekunde. Signerte avtaler utløser også neste støtterunde fra Innovasjon Norge.</a:t>
             </a:r>
             <a:endParaRPr lang="en-US" sz="1600" dirty="0"/>
           </a:p>
@@ -5582,7 +5526,7 @@
                 <a:ea typeface="Calibri" pitchFamily="34" charset="-122"/>
                 <a:cs typeface="Calibri" pitchFamily="34" charset="-120"/>
               </a:rPr>
-              <a:t>Pris: 10 000 kr per fartøy per måned, ekskl. mva.</a:t>
+              <a:t>Pris: 1 000 kr per modul per fartøy per måned, 14 000 kr for alle 14 moduler, ekskl. mva.</a:t>
             </a:r>
             <a:endParaRPr lang="en-US" sz="1500" dirty="0"/>
           </a:p>
@@ -9844,7 +9788,7 @@
                 <a:ea typeface="Calibri" pitchFamily="34" charset="-122"/>
                 <a:cs typeface="Calibri" pitchFamily="34" charset="-120"/>
               </a:rPr>
-              <a:t>Data i Norge/EU</a:t>
+              <a:t>Data lagres i Norge</a:t>
             </a:r>
             <a:endParaRPr lang="en-US" sz="1700" dirty="0"/>
           </a:p>
@@ -9861,7 +9805,7 @@
                 <a:ea typeface="Calibri" pitchFamily="34" charset="-122"/>
                 <a:cs typeface="Calibri" pitchFamily="34" charset="-120"/>
               </a:rPr>
-              <a:t>Kundens data brukes ikke til å trene KI-modeller.</a:t>
+              <a:t>På egen server i Norge. Kundens data brukes ikke til å trene KI-modeller.</a:t>
             </a:r>
             <a:endParaRPr lang="en-US" sz="1700" dirty="0"/>
           </a:p>
@@ -11654,7 +11598,7 @@
                 <a:ea typeface="Calibri" pitchFamily="34" charset="-122"/>
                 <a:cs typeface="Calibri" pitchFamily="34" charset="-120"/>
               </a:rPr>
-              <a:t>≈ 31 MNOK per år</a:t>
+              <a:t>≈ 44 MNOK per år</a:t>
             </a:r>
             <a:endParaRPr lang="en-US" sz="1300" dirty="0"/>
           </a:p>
@@ -11807,7 +11751,7 @@
                 <a:ea typeface="Calibri" pitchFamily="34" charset="-122"/>
                 <a:cs typeface="Calibri" pitchFamily="34" charset="-120"/>
               </a:rPr>
-              <a:t>≈ 272 MNOK per år</a:t>
+              <a:t>≈ 381 MNOK per år</a:t>
             </a:r>
             <a:endParaRPr lang="en-US" sz="1300" dirty="0"/>
           </a:p>
@@ -11960,7 +11904,7 @@
                 <a:ea typeface="Calibri" pitchFamily="34" charset="-122"/>
                 <a:cs typeface="Calibri" pitchFamily="34" charset="-120"/>
               </a:rPr>
-              <a:t>≈ 300 MNOK per år</a:t>
+              <a:t>≈ 425 MNOK per år</a:t>
             </a:r>
             <a:endParaRPr lang="en-US" sz="1300" dirty="0"/>
           </a:p>
@@ -12049,7 +11993,7 @@
                   <a:srgbClr val="5B6B7A"/>
                 </a:solidFill>
               </a:rPr>
-              <a:t>Årlig abonnementsverdi ved 120 000 kr per fartøy og full dekning. Kilder: Fiskeridirektoratet, Nøkkeltal 2025 (foreløpige tall); EUs fartøyregister, 2021-tall.</a:t>
+              <a:t>Årlig abonnementsverdi ved 168 000 kr per fartøy (alle moduler) og full dekning. Kilder: Fiskeridirektoratet, Nøkkeltal 2025 (foreløpige tall); EUs fartøyregister, 2021-tall.</a:t>
             </a:r>
             <a:endParaRPr lang="en-US" sz="1100" dirty="0"/>
           </a:p>
@@ -12204,7 +12148,7 @@
                 <a:ea typeface="Arial" pitchFamily="34" charset="-122"/>
                 <a:cs typeface="Arial" pitchFamily="34" charset="-120"/>
               </a:rPr>
-              <a:t>Fast abonnement per fartøy – inntekten vokser med flåten</a:t>
+              <a:t>Abonnement per fartøy og modul – inntekten vokser med flåten</a:t>
             </a:r>
             <a:endParaRPr lang="en-US" sz="3000" dirty="0"/>
           </a:p>
@@ -12243,7 +12187,7 @@
                 <a:ea typeface="Arial" pitchFamily="34" charset="-122"/>
                 <a:cs typeface="Arial" pitchFamily="34" charset="-120"/>
               </a:rPr>
-              <a:t>10 000 kr</a:t>
+              <a:t>14 000 kr</a:t>
             </a:r>
             <a:endParaRPr lang="en-US" sz="5400" dirty="0"/>
           </a:p>
@@ -12260,7 +12204,7 @@
                 <a:ea typeface="Calibri" pitchFamily="34" charset="-122"/>
                 <a:cs typeface="Calibri" pitchFamily="34" charset="-120"/>
               </a:rPr>
-              <a:t>per fartøy per måned</a:t>
+              <a:t>per fartøy per måned for alle 14 moduler</a:t>
             </a:r>
             <a:endParaRPr lang="en-US" sz="5400" dirty="0"/>
           </a:p>
@@ -12277,7 +12221,7 @@
                 <a:ea typeface="Calibri" pitchFamily="34" charset="-122"/>
                 <a:cs typeface="Calibri" pitchFamily="34" charset="-120"/>
               </a:rPr>
-              <a:t>= 120 000 kr per fartøy per år, ekskl. mva.</a:t>
+              <a:t>= 168 000 kr per fartøy per år, ekskl. mva.</a:t>
             </a:r>
             <a:endParaRPr lang="en-US" sz="5400" dirty="0"/>
           </a:p>
@@ -12360,7 +12304,7 @@
                 <a:ea typeface="Calibri" pitchFamily="34" charset="-122"/>
                 <a:cs typeface="Calibri" pitchFamily="34" charset="-120"/>
               </a:rPr>
-              <a:t>Gjentakende inntekt fra hvert fartøy</a:t>
+              <a:t>Moduler fra 1 000 kr per måned – kunden kan starte smått</a:t>
             </a:r>
             <a:endParaRPr lang="en-US" sz="1500" dirty="0"/>
           </a:p>

</xml_diff>